<commit_message>
Critical-audit fixes: blank doc-PDF page, cramped pitch S10 column
- Documentation PDF regenerated with JavaScript disabled: GSAP's
  scroll-triggered from-states (opacity 0) were swallowing below-fold content
  in the print (page 3 measured near-blank, pixel stddev 2.2). The page is
  fully CSS-visible without JS; all 9 pages now verified non-blank
  (stddev 45–101).
- Pitch S10 rebuilt: the V2 lessons column was 1.25in wide at 9.5pt (would
  wrap badly). Now balanced photo+text pairs for V1 and V2, kicker names the
  bench tests explicitly, V2 gains the varnish+vinyl acceptance line.
- Blank-check added to QA: pitch 13/13 pages with content.

Co-Authored-By: Claude Opus 4.8 <noreply@anthropic.com>
Claude-Session: https://claude.ai/code/session_012oiKWFH9ehAkC5KpJS8ah9
</commit_message>
<xml_diff>
--- a/entrega/CadeiraBeni_pitch.pptx
+++ b/entrega/CadeiraBeni_pitch.pptx
@@ -2725,7 +2725,7 @@
                 <a:ea typeface="IBM Plex Mono" pitchFamily="34" charset="-122"/>
                 <a:cs typeface="IBM Plex Mono" pitchFamily="34" charset="-120"/>
               </a:rPr>
-              <a:t>3 · PROCESSO PRODUTIVO — ERROS E ACERTOS</a:t>
+              <a:t>3 · PROCESSO PRODUTIVO — TESTES DE BANCADA, ERROS E ACERTOS</a:t>
             </a:r>
             <a:endParaRPr lang="en-US" sz="1050" dirty="0"/>
           </a:p>
@@ -2783,13 +2783,13 @@
         </p:nvPicPr>
         <p:blipFill>
           <a:blip r:embed="rId1"/>
-          <a:srcRect l="0" r="0" t="181" b="181"/>
+          <a:srcRect l="0" r="0" t="0" b="0"/>
           <a:stretch/>
         </p:blipFill>
         <p:spPr>
           <a:xfrm>
-            <a:off x="411480" y="1554480"/>
-            <a:ext cx="2103120" cy="2011680"/>
+            <a:off x="411480" y="1572768"/>
+            <a:ext cx="1828800" cy="2148840"/>
           </a:xfrm>
           <a:prstGeom prst="rect">
             <a:avLst/>
@@ -2804,8 +2804,8 @@
         </p:nvSpPr>
         <p:spPr>
           <a:xfrm rot="-360000">
-            <a:off x="502920" y="1700784"/>
-            <a:ext cx="1463040" cy="310896"/>
+            <a:off x="475488" y="1700784"/>
+            <a:ext cx="1371600" cy="292608"/>
           </a:xfrm>
           <a:prstGeom prst="rect">
             <a:avLst/>
@@ -2825,7 +2825,7 @@
               <a:buNone/>
             </a:pPr>
             <a:r>
-              <a:rPr lang="en-US" sz="1100" spc="200" kern="0" dirty="0">
+              <a:rPr lang="en-US" sz="1050" spc="200" kern="0" dirty="0">
                 <a:solidFill>
                   <a:srgbClr val="D65A2B"/>
                 </a:solidFill>
@@ -2835,7 +2835,7 @@
               </a:rPr>
               <a:t>NÃO FECHOU</a:t>
             </a:r>
-            <a:endParaRPr lang="en-US" sz="1100" dirty="0"/>
+            <a:endParaRPr lang="en-US" sz="1050" dirty="0"/>
           </a:p>
         </p:txBody>
       </p:sp>
@@ -2847,8 +2847,8 @@
         </p:nvSpPr>
         <p:spPr>
           <a:xfrm>
-            <a:off x="411480" y="3657600"/>
-            <a:ext cx="2286000" cy="219456"/>
+            <a:off x="411480" y="3767328"/>
+            <a:ext cx="2011680" cy="329184"/>
           </a:xfrm>
           <a:prstGeom prst="rect">
             <a:avLst/>
@@ -2864,7 +2864,7 @@
               <a:buNone/>
             </a:pPr>
             <a:r>
-              <a:rPr lang="en-US" sz="850" spc="100" kern="0" dirty="0">
+              <a:rPr lang="en-US" sz="800" spc="100" kern="0" dirty="0">
                 <a:solidFill>
                   <a:srgbClr val="8A7B60"/>
                 </a:solidFill>
@@ -2874,7 +2874,7 @@
               </a:rPr>
               <a:t>V1 · PÉS E BRAÇOS EM MARCHETARIA</a:t>
             </a:r>
-            <a:endParaRPr lang="en-US" sz="850" dirty="0"/>
+            <a:endParaRPr lang="en-US" sz="800" dirty="0"/>
           </a:p>
         </p:txBody>
       </p:sp>
@@ -2886,8 +2886,8 @@
         </p:nvSpPr>
         <p:spPr>
           <a:xfrm>
-            <a:off x="2697480" y="1627632"/>
-            <a:ext cx="2834640" cy="2194560"/>
+            <a:off x="2395728" y="1609344"/>
+            <a:ext cx="2148840" cy="2377440"/>
           </a:xfrm>
           <a:prstGeom prst="rect">
             <a:avLst/>
@@ -2901,13 +2901,13 @@
           <a:p>
             <a:pPr marL="342900" indent="-342900">
               <a:lnSpc>
-                <a:spcPct val="125000"/>
+                <a:spcPct val="122000"/>
               </a:lnSpc>
               <a:buSzPct val="100000"/>
               <a:buChar char="•"/>
             </a:pPr>
             <a:r>
-              <a:rPr lang="en-US" sz="1100" dirty="0">
+              <a:rPr lang="en-US" sz="1050" dirty="0">
                 <a:solidFill>
                   <a:srgbClr val="3A362E"/>
                 </a:solidFill>
@@ -2915,20 +2915,20 @@
                 <a:ea typeface="IBM Plex Sans" pitchFamily="34" charset="-122"/>
                 <a:cs typeface="IBM Plex Sans" pitchFamily="34" charset="-120"/>
               </a:rPr>
-              <a:t>Densidade variável: cada pé saía diferente.</a:t>
-            </a:r>
-            <a:endParaRPr lang="en-US" sz="1100" dirty="0"/>
+              <a:t>Densidade variável: cada pé saía diferente na bancada.</a:t>
+            </a:r>
+            <a:endParaRPr lang="en-US" sz="1050" dirty="0"/>
           </a:p>
           <a:p>
             <a:pPr marL="342900" indent="-342900">
               <a:lnSpc>
-                <a:spcPct val="125000"/>
+                <a:spcPct val="122000"/>
               </a:lnSpc>
               <a:buSzPct val="100000"/>
               <a:buChar char="•"/>
             </a:pPr>
             <a:r>
-              <a:rPr lang="en-US" sz="1100" dirty="0">
+              <a:rPr lang="en-US" sz="1050" dirty="0">
                 <a:solidFill>
                   <a:srgbClr val="3A362E"/>
                 </a:solidFill>
@@ -2936,20 +2936,20 @@
                 <a:ea typeface="IBM Plex Sans" pitchFamily="34" charset="-122"/>
                 <a:cs typeface="IBM Plex Sans" pitchFamily="34" charset="-120"/>
               </a:rPr>
-              <a:t>Exigia precisão que a madeira de reuso não dá.</a:t>
-            </a:r>
-            <a:endParaRPr lang="en-US" sz="1100" dirty="0"/>
+              <a:t>Marchetaria exigia precisão que a madeira de reuso não dá.</a:t>
+            </a:r>
+            <a:endParaRPr lang="en-US" sz="1050" dirty="0"/>
           </a:p>
           <a:p>
             <a:pPr marL="342900" indent="-342900">
               <a:lnSpc>
-                <a:spcPct val="125000"/>
+                <a:spcPct val="122000"/>
               </a:lnSpc>
               <a:buSzPct val="100000"/>
               <a:buChar char="•"/>
             </a:pPr>
             <a:r>
-              <a:rPr lang="en-US" sz="1100" dirty="0">
+              <a:rPr lang="en-US" sz="1050" dirty="0">
                 <a:solidFill>
                   <a:srgbClr val="3A362E"/>
                 </a:solidFill>
@@ -2957,9 +2957,30 @@
                 <a:ea typeface="IBM Plex Sans" pitchFamily="34" charset="-122"/>
                 <a:cs typeface="IBM Plex Sans" pitchFamily="34" charset="-120"/>
               </a:rPr>
-              <a:t>Estética colada: quebrou uma parte, perdeu a peça. E ficou pesada.</a:t>
-            </a:r>
-            <a:endParaRPr lang="en-US" sz="1100" dirty="0"/>
+              <a:t>Estética colada: quebrou uma parte, perdeu a peça.</a:t>
+            </a:r>
+            <a:endParaRPr lang="en-US" sz="1050" dirty="0"/>
+          </a:p>
+          <a:p>
+            <a:pPr marL="342900" indent="-342900">
+              <a:lnSpc>
+                <a:spcPct val="122000"/>
+              </a:lnSpc>
+              <a:buSzPct val="100000"/>
+              <a:buChar char="•"/>
+            </a:pPr>
+            <a:r>
+              <a:rPr lang="en-US" sz="1050" dirty="0">
+                <a:solidFill>
+                  <a:srgbClr val="3A362E"/>
+                </a:solidFill>
+                <a:latin typeface="IBM Plex Sans" pitchFamily="34" charset="0"/>
+                <a:ea typeface="IBM Plex Sans" pitchFamily="34" charset="-122"/>
+                <a:cs typeface="IBM Plex Sans" pitchFamily="34" charset="-120"/>
+              </a:rPr>
+              <a:t>E ficou pesada de mover e limpar.</a:t>
+            </a:r>
+            <a:endParaRPr lang="en-US" sz="1050" dirty="0"/>
           </a:p>
         </p:txBody>
       </p:sp>
@@ -2978,8 +2999,8 @@
         </p:blipFill>
         <p:spPr>
           <a:xfrm>
-            <a:off x="5806440" y="1554480"/>
-            <a:ext cx="2011680" cy="2011680"/>
+            <a:off x="4709160" y="1572768"/>
+            <a:ext cx="1828800" cy="2148840"/>
           </a:xfrm>
           <a:prstGeom prst="rect">
             <a:avLst/>
@@ -2994,8 +3015,8 @@
         </p:nvSpPr>
         <p:spPr>
           <a:xfrm rot="-360000">
-            <a:off x="5897880" y="1700784"/>
-            <a:ext cx="1737360" cy="310896"/>
+            <a:off x="4754880" y="1700784"/>
+            <a:ext cx="1600200" cy="292608"/>
           </a:xfrm>
           <a:prstGeom prst="rect">
             <a:avLst/>
@@ -3015,7 +3036,7 @@
               <a:buNone/>
             </a:pPr>
             <a:r>
-              <a:rPr lang="en-US" sz="1100" spc="200" kern="0" dirty="0">
+              <a:rPr lang="en-US" sz="1000" spc="200" kern="0" dirty="0">
                 <a:solidFill>
                   <a:srgbClr val="243D2C"/>
                 </a:solidFill>
@@ -3025,7 +3046,7 @@
               </a:rPr>
               <a:t>MAIS REPARÁVEL</a:t>
             </a:r>
-            <a:endParaRPr lang="en-US" sz="1100" dirty="0"/>
+            <a:endParaRPr lang="en-US" sz="1000" dirty="0"/>
           </a:p>
         </p:txBody>
       </p:sp>
@@ -3037,8 +3058,8 @@
         </p:nvSpPr>
         <p:spPr>
           <a:xfrm>
-            <a:off x="5806440" y="3657600"/>
-            <a:ext cx="2286000" cy="219456"/>
+            <a:off x="4709160" y="3767328"/>
+            <a:ext cx="2011680" cy="329184"/>
           </a:xfrm>
           <a:prstGeom prst="rect">
             <a:avLst/>
@@ -3054,7 +3075,7 @@
               <a:buNone/>
             </a:pPr>
             <a:r>
-              <a:rPr lang="en-US" sz="850" spc="100" kern="0" dirty="0">
+              <a:rPr lang="en-US" sz="800" spc="100" kern="0" dirty="0">
                 <a:solidFill>
                   <a:srgbClr val="8A7B60"/>
                 </a:solidFill>
@@ -3064,7 +3085,7 @@
               </a:rPr>
               <a:t>V2 · ESTACAS DE BAMBU</a:t>
             </a:r>
-            <a:endParaRPr lang="en-US" sz="850" dirty="0"/>
+            <a:endParaRPr lang="en-US" sz="800" dirty="0"/>
           </a:p>
         </p:txBody>
       </p:sp>
@@ -3076,8 +3097,8 @@
         </p:nvSpPr>
         <p:spPr>
           <a:xfrm>
-            <a:off x="7955280" y="1627632"/>
-            <a:ext cx="1143000" cy="2377440"/>
+            <a:off x="6693408" y="1609344"/>
+            <a:ext cx="2148840" cy="2377440"/>
           </a:xfrm>
           <a:prstGeom prst="rect">
             <a:avLst/>
@@ -3091,13 +3112,13 @@
           <a:p>
             <a:pPr marL="342900" indent="-342900">
               <a:lnSpc>
-                <a:spcPct val="120000"/>
+                <a:spcPct val="122000"/>
               </a:lnSpc>
               <a:buSzPct val="100000"/>
               <a:buChar char="•"/>
             </a:pPr>
             <a:r>
-              <a:rPr lang="en-US" sz="950" dirty="0">
+              <a:rPr lang="en-US" sz="1050" dirty="0">
                 <a:solidFill>
                   <a:srgbClr val="3A362E"/>
                 </a:solidFill>
@@ -3107,18 +3128,18 @@
               </a:rPr>
               <a:t>Estrutura e pernas viraram partes independentes.</a:t>
             </a:r>
-            <a:endParaRPr lang="en-US" sz="950" dirty="0"/>
+            <a:endParaRPr lang="en-US" sz="1050" dirty="0"/>
           </a:p>
           <a:p>
             <a:pPr marL="342900" indent="-342900">
               <a:lnSpc>
-                <a:spcPct val="120000"/>
+                <a:spcPct val="122000"/>
               </a:lnSpc>
               <a:buSzPct val="100000"/>
               <a:buChar char="•"/>
             </a:pPr>
             <a:r>
-              <a:rPr lang="en-US" sz="950" dirty="0">
+              <a:rPr lang="en-US" sz="1050" dirty="0">
                 <a:solidFill>
                   <a:srgbClr val="3A362E"/>
                 </a:solidFill>
@@ -3128,18 +3149,18 @@
               </a:rPr>
               <a:t>Estaca padronizada: sai uma, entra outra.</a:t>
             </a:r>
-            <a:endParaRPr lang="en-US" sz="950" dirty="0"/>
+            <a:endParaRPr lang="en-US" sz="1050" dirty="0"/>
           </a:p>
           <a:p>
             <a:pPr marL="342900" indent="-342900">
               <a:lnSpc>
-                <a:spcPct val="120000"/>
+                <a:spcPct val="122000"/>
               </a:lnSpc>
               <a:buSzPct val="100000"/>
               <a:buChar char="•"/>
             </a:pPr>
             <a:r>
-              <a:rPr lang="en-US" sz="950" dirty="0">
+              <a:rPr lang="en-US" sz="1050" dirty="0">
                 <a:solidFill>
                   <a:srgbClr val="3A362E"/>
                 </a:solidFill>
@@ -3147,9 +3168,30 @@
                 <a:ea typeface="IBM Plex Sans" pitchFamily="34" charset="-122"/>
                 <a:cs typeface="IBM Plex Sans" pitchFamily="34" charset="-120"/>
               </a:rPr>
-              <a:t>Menos madeira na base — mais leve de mover e limpar.</a:t>
-            </a:r>
-            <a:endParaRPr lang="en-US" sz="950" dirty="0"/>
+              <a:t>Menos madeira na base — mais leve.</a:t>
+            </a:r>
+            <a:endParaRPr lang="en-US" sz="1050" dirty="0"/>
+          </a:p>
+          <a:p>
+            <a:pPr marL="342900" indent="-342900">
+              <a:lnSpc>
+                <a:spcPct val="122000"/>
+              </a:lnSpc>
+              <a:buSzPct val="100000"/>
+              <a:buChar char="•"/>
+            </a:pPr>
+            <a:r>
+              <a:rPr lang="en-US" sz="1050" dirty="0">
+                <a:solidFill>
+                  <a:srgbClr val="3A362E"/>
+                </a:solidFill>
+                <a:latin typeface="IBM Plex Sans" pitchFamily="34" charset="0"/>
+                <a:ea typeface="IBM Plex Sans" pitchFamily="34" charset="-122"/>
+                <a:cs typeface="IBM Plex Sans" pitchFamily="34" charset="-120"/>
+              </a:rPr>
+              <a:t>Verniz + vinil no acabamento: resiste a unha, xixi e mordida.</a:t>
+            </a:r>
+            <a:endParaRPr lang="en-US" sz="1050" dirty="0"/>
           </a:p>
         </p:txBody>
       </p:sp>

</xml_diff>

<commit_message>
Corrige validação com frases da Entrega 1, remove espuma e ajusta nome da disciplina para PAS
- Slide de validação agora usa certezas/suposições reais da pesquisa (higiene obrigatória, protocolo de sanitização, peroba/jacarandá só por reuso)
- Problema sistêmico e proposta de valor reenquadrados em madeira (insumo virgem vs madeira que já existia), sem espuma
- Nome da disciplina corrigido para PAS — Projeto Aplicado em Sustentabilidade no site, rodapés dos slides e documentação
- Entregáveis regenerados: PPTX, PDF do pitch (fontes embutidas), HTML single-file e PDF da documentação

Co-Authored-By: Claude Fable 5 <noreply@anthropic.com>
Claude-Session: https://claude.ai/code/session_012oiKWFH9ehAkC5KpJS8ah9
</commit_message>
<xml_diff>
--- a/entrega/CadeiraBeni_pitch.pptx
+++ b/entrega/CadeiraBeni_pitch.pptx
@@ -2456,7 +2456,7 @@
                 <a:ea typeface="IBM Plex Mono" pitchFamily="34" charset="-122"/>
                 <a:cs typeface="IBM Plex Mono" pitchFamily="34" charset="-120"/>
               </a:rPr>
-              <a:t>Luiza Britto · Design Thinking e Prototipagem · Insper · 02 jul 2026</a:t>
+              <a:t>Luiza Britto · PAS — Projeto Aplicado em Sustentabilidade · Insper · 02 jul 2026</a:t>
             </a:r>
             <a:endParaRPr lang="en-US" sz="800" dirty="0"/>
           </a:p>
@@ -3125,7 +3125,7 @@
                 <a:ea typeface="IBM Plex Mono" pitchFamily="34" charset="-122"/>
                 <a:cs typeface="IBM Plex Mono" pitchFamily="34" charset="-120"/>
               </a:rPr>
-              <a:t>Luiza Britto · Design Thinking e Prototipagem · Insper · 02 jul 2026</a:t>
+              <a:t>Luiza Britto · PAS — Projeto Aplicado em Sustentabilidade · Insper · 02 jul 2026</a:t>
             </a:r>
             <a:endParaRPr lang="en-US" sz="800" dirty="0"/>
           </a:p>
@@ -3907,7 +3907,7 @@
                 <a:ea typeface="IBM Plex Mono" pitchFamily="34" charset="-122"/>
                 <a:cs typeface="IBM Plex Mono" pitchFamily="34" charset="-120"/>
               </a:rPr>
-              <a:t>Luiza Britto · Design Thinking e Prototipagem · Insper · 02 jul 2026</a:t>
+              <a:t>Luiza Britto · PAS — Projeto Aplicado em Sustentabilidade · Insper · 02 jul 2026</a:t>
             </a:r>
             <a:endParaRPr lang="en-US" sz="800" dirty="0"/>
           </a:p>
@@ -4489,7 +4489,7 @@
                 <a:ea typeface="IBM Plex Mono" pitchFamily="34" charset="-122"/>
                 <a:cs typeface="IBM Plex Mono" pitchFamily="34" charset="-120"/>
               </a:rPr>
-              <a:t>Luiza Britto · Design Thinking e Prototipagem · Insper · 02 jul 2026</a:t>
+              <a:t>Luiza Britto · PAS — Projeto Aplicado em Sustentabilidade · Insper · 02 jul 2026</a:t>
             </a:r>
             <a:endParaRPr lang="en-US" sz="800" dirty="0"/>
           </a:p>
@@ -5686,7 +5686,7 @@
                 <a:ea typeface="IBM Plex Sans" pitchFamily="34" charset="-122"/>
                 <a:cs typeface="IBM Plex Sans" pitchFamily="34" charset="-120"/>
               </a:rPr>
-              <a:t>Madeira urbana de qualidade vira descarte volumoso; o setor roda em espuma e plástico virgem.</a:t>
+              <a:t>Madeira maciça de móveis antigos vira descarte volumoso — e cada peça reusada substitui madeira nova.</a:t>
             </a:r>
             <a:endParaRPr lang="en-US" sz="1400" dirty="0"/>
           </a:p>
@@ -5959,7 +5959,7 @@
                 <a:ea typeface="IBM Plex Mono" pitchFamily="34" charset="-122"/>
                 <a:cs typeface="IBM Plex Mono" pitchFamily="34" charset="-120"/>
               </a:rPr>
-              <a:t>Luiza Britto · Design Thinking e Prototipagem · Insper · 02 jul 2026</a:t>
+              <a:t>Luiza Britto · PAS — Projeto Aplicado em Sustentabilidade · Insper · 02 jul 2026</a:t>
             </a:r>
             <a:endParaRPr lang="en-US" sz="800" dirty="0"/>
           </a:p>
@@ -6504,7 +6504,7 @@
                 <a:ea typeface="IBM Plex Mono" pitchFamily="34" charset="-122"/>
                 <a:cs typeface="IBM Plex Mono" pitchFamily="34" charset="-120"/>
               </a:rPr>
-              <a:t>Luiza Britto · Design Thinking e Prototipagem · Insper · 02 jul 2026</a:t>
+              <a:t>Luiza Britto · PAS — Projeto Aplicado em Sustentabilidade · Insper · 02 jul 2026</a:t>
             </a:r>
             <a:endParaRPr lang="en-US" sz="800" dirty="0"/>
           </a:p>
@@ -6695,7 +6695,7 @@
                 <a:ea typeface="IBM Plex Mono" pitchFamily="34" charset="-122"/>
                 <a:cs typeface="IBM Plex Mono" pitchFamily="34" charset="-120"/>
               </a:rPr>
-              <a:t>VALIDAÇÃO · 6 CONVERSAS — TUTORES, MARCENEIROS, VETERINÁRIO, CATADORES</a:t>
+              <a:t>VALIDAÇÃO · CERTEZAS &amp; SUPOSIÇÕES DA PESQUISA · 6 ENTREVISTAS — TUTORES, MARCENEIRO, VETERINÁRIO, CATADOR</a:t>
             </a:r>
             <a:endParaRPr lang="en-US" sz="1050" dirty="0"/>
           </a:p>
@@ -6754,7 +6754,7 @@
                 <a:ea typeface="Instrument Serif" pitchFamily="34" charset="-122"/>
                 <a:cs typeface="Instrument Serif" pitchFamily="34" charset="-120"/>
               </a:rPr>
-              <a:t>“Se parecer móvel, eu deixo na sala.”</a:t>
+              <a:t>“Higiene — urina, pelos, ácaros — é fator obrigatório de aceitação.”</a:t>
             </a:r>
             <a:endParaRPr lang="en-US" sz="2300" dirty="0"/>
           </a:p>
@@ -6793,7 +6793,7 @@
                 <a:ea typeface="IBM Plex Mono" pitchFamily="34" charset="-122"/>
                 <a:cs typeface="IBM Plex Mono" pitchFamily="34" charset="-120"/>
               </a:rPr>
-              <a:t>TUTORA      →  VIROU: LINGUAGEM DE MÓVEL</a:t>
+              <a:t>CERTEZA · PESQUISA      →  VIROU: VERNIZ LAVÁVEL AGORA, CAPA REMOVÍVEL NO ROADMAP</a:t>
             </a:r>
             <a:endParaRPr lang="en-US" sz="900" dirty="0"/>
           </a:p>
@@ -6852,7 +6852,7 @@
                 <a:ea typeface="Instrument Serif" pitchFamily="34" charset="-122"/>
                 <a:cs typeface="Instrument Serif" pitchFamily="34" charset="-120"/>
               </a:rPr>
-              <a:t>“Lavável não é diferencial. É requisito.”</a:t>
+              <a:t>“Só confio no reaproveitado com protocolo claro de sanitização.”</a:t>
             </a:r>
             <a:endParaRPr lang="en-US" sz="2300" dirty="0"/>
           </a:p>
@@ -6891,7 +6891,7 @@
                 <a:ea typeface="IBM Plex Mono" pitchFamily="34" charset="-122"/>
                 <a:cs typeface="IBM Plex Mono" pitchFamily="34" charset="-120"/>
               </a:rPr>
-              <a:t>SÍNTESE      →  VIROU: CAPA LAVÁVEL NO ROADMAP</a:t>
+              <a:t>SUPOSIÇÃO · CONSUMIDORES      →  VIROU: TRIAGEM, TRATAMENTO E VERNIZ NO PROCESSO</a:t>
             </a:r>
             <a:endParaRPr lang="en-US" sz="900" dirty="0"/>
           </a:p>
@@ -6950,7 +6950,7 @@
                 <a:ea typeface="Instrument Serif" pitchFamily="34" charset="-122"/>
                 <a:cs typeface="Instrument Serif" pitchFamily="34" charset="-120"/>
               </a:rPr>
-              <a:t>“Madeira reaproveitada precisa vir com cuidado.”</a:t>
+              <a:t>“Peroba e jacarandá, hoje, só se obtêm por reuso.”</a:t>
             </a:r>
             <a:endParaRPr lang="en-US" sz="2300" dirty="0"/>
           </a:p>
@@ -6989,7 +6989,7 @@
                 <a:ea typeface="IBM Plex Mono" pitchFamily="34" charset="-122"/>
                 <a:cs typeface="IBM Plex Mono" pitchFamily="34" charset="-120"/>
               </a:rPr>
-              <a:t>MARCENEIRO · VETERINÁRIO      →  VIROU: TRIAGEM + SANITIZAÇÃO</a:t>
+              <a:t>CERTEZA · MADEIRA-FONTE      →  VIROU: MINERAÇÃO URBANA COMO VALOR</a:t>
             </a:r>
             <a:endParaRPr lang="en-US" sz="900" dirty="0"/>
           </a:p>
@@ -7028,7 +7028,7 @@
                 <a:ea typeface="IBM Plex Mono" pitchFamily="34" charset="-122"/>
                 <a:cs typeface="IBM Plex Mono" pitchFamily="34" charset="-120"/>
               </a:rPr>
-              <a:t>Luiza Britto · Design Thinking e Prototipagem · Insper · 02 jul 2026</a:t>
+              <a:t>Luiza Britto · PAS — Projeto Aplicado em Sustentabilidade · Insper · 02 jul 2026</a:t>
             </a:r>
             <a:endParaRPr lang="en-US" sz="800" dirty="0"/>
           </a:p>
@@ -7418,7 +7418,7 @@
                 <a:ea typeface="IBM Plex Sans" pitchFamily="34" charset="-122"/>
                 <a:cs typeface="IBM Plex Sans" pitchFamily="34" charset="-120"/>
               </a:rPr>
-              <a:t>Espuma + plástico virgem</a:t>
+              <a:t>Madeira nova, insumo virgem</a:t>
             </a:r>
             <a:endParaRPr lang="en-US" sz="1400" dirty="0"/>
           </a:p>
@@ -7759,7 +7759,7 @@
                 <a:ea typeface="IBM Plex Mono" pitchFamily="34" charset="-122"/>
                 <a:cs typeface="IBM Plex Mono" pitchFamily="34" charset="-120"/>
               </a:rPr>
-              <a:t>Luiza Britto · Design Thinking e Prototipagem · Insper · 02 jul 2026</a:t>
+              <a:t>Luiza Britto · PAS — Projeto Aplicado em Sustentabilidade · Insper · 02 jul 2026</a:t>
             </a:r>
             <a:endParaRPr lang="en-US" sz="800" dirty="0"/>
           </a:p>
@@ -8819,7 +8819,7 @@
                 <a:ea typeface="IBM Plex Mono" pitchFamily="34" charset="-122"/>
                 <a:cs typeface="IBM Plex Mono" pitchFamily="34" charset="-120"/>
               </a:rPr>
-              <a:t>Luiza Britto · Design Thinking e Prototipagem · Insper · 02 jul 2026</a:t>
+              <a:t>Luiza Britto · PAS — Projeto Aplicado em Sustentabilidade · Insper · 02 jul 2026</a:t>
             </a:r>
             <a:endParaRPr lang="en-US" sz="800" dirty="0"/>
           </a:p>
@@ -9138,7 +9138,7 @@
                 <a:ea typeface="IBM Plex Mono" pitchFamily="34" charset="-122"/>
                 <a:cs typeface="IBM Plex Mono" pitchFamily="34" charset="-120"/>
               </a:rPr>
-              <a:t>Luiza Britto · Design Thinking e Prototipagem · Insper · 02 jul 2026</a:t>
+              <a:t>Luiza Britto · PAS — Projeto Aplicado em Sustentabilidade · Insper · 02 jul 2026</a:t>
             </a:r>
             <a:endParaRPr lang="en-US" sz="800" dirty="0"/>
           </a:p>
@@ -9719,7 +9719,7 @@
                 <a:ea typeface="IBM Plex Mono" pitchFamily="34" charset="-122"/>
                 <a:cs typeface="IBM Plex Mono" pitchFamily="34" charset="-120"/>
               </a:rPr>
-              <a:t>Luiza Britto · Design Thinking e Prototipagem · Insper · 02 jul 2026</a:t>
+              <a:t>Luiza Britto · PAS — Projeto Aplicado em Sustentabilidade · Insper · 02 jul 2026</a:t>
             </a:r>
             <a:endParaRPr lang="en-US" sz="800" dirty="0"/>
           </a:p>
@@ -10513,7 +10513,7 @@
                 <a:ea typeface="IBM Plex Mono" pitchFamily="34" charset="-122"/>
                 <a:cs typeface="IBM Plex Mono" pitchFamily="34" charset="-120"/>
               </a:rPr>
-              <a:t>Luiza Britto · Design Thinking e Prototipagem · Insper · 02 jul 2026</a:t>
+              <a:t>Luiza Britto · PAS — Projeto Aplicado em Sustentabilidade · Insper · 02 jul 2026</a:t>
             </a:r>
             <a:endParaRPr lang="en-US" sz="800" dirty="0"/>
           </a:p>

</xml_diff>

<commit_message>
Corrige PAS para Programa Avançado de Sustentabilidade e remove arcos das fotos
- Nome da disciplina corrigido em site, pitch, roteiro, manual e documentação
- Fotos editoriais agora em retângulo arredondado (raio do sistema) com a
  mesma sombra dura — arcos removidos; formato único em todas as imagens
- Todos os PDFs regenerados

Co-Authored-By: Claude Fable 5 <noreply@anthropic.com>
Claude-Session: https://claude.ai/code/session_012oiKWFH9ehAkC5KpJS8ah9
</commit_message>
<xml_diff>
--- a/entrega/CadeiraBeni_pitch.pptx
+++ b/entrega/CadeiraBeni_pitch.pptx
@@ -2456,7 +2456,7 @@
                 <a:ea typeface="IBM Plex Mono" pitchFamily="34" charset="-122"/>
                 <a:cs typeface="IBM Plex Mono" pitchFamily="34" charset="-120"/>
               </a:rPr>
-              <a:t>Luiza Britto · PAS — Projeto Aplicado em Sustentabilidade · Insper · 02 jul 2026</a:t>
+              <a:t>Luiza Britto · PAS — Programa Avançado de Sustentabilidade · Insper · 02 jul 2026</a:t>
             </a:r>
             <a:endParaRPr lang="en-US" sz="800" dirty="0"/>
           </a:p>
@@ -3125,7 +3125,7 @@
                 <a:ea typeface="IBM Plex Mono" pitchFamily="34" charset="-122"/>
                 <a:cs typeface="IBM Plex Mono" pitchFamily="34" charset="-120"/>
               </a:rPr>
-              <a:t>Luiza Britto · PAS — Projeto Aplicado em Sustentabilidade · Insper · 02 jul 2026</a:t>
+              <a:t>Luiza Britto · PAS — Programa Avançado de Sustentabilidade · Insper · 02 jul 2026</a:t>
             </a:r>
             <a:endParaRPr lang="en-US" sz="800" dirty="0"/>
           </a:p>
@@ -3907,7 +3907,7 @@
                 <a:ea typeface="IBM Plex Mono" pitchFamily="34" charset="-122"/>
                 <a:cs typeface="IBM Plex Mono" pitchFamily="34" charset="-120"/>
               </a:rPr>
-              <a:t>Luiza Britto · PAS — Projeto Aplicado em Sustentabilidade · Insper · 02 jul 2026</a:t>
+              <a:t>Luiza Britto · PAS — Programa Avançado de Sustentabilidade · Insper · 02 jul 2026</a:t>
             </a:r>
             <a:endParaRPr lang="en-US" sz="800" dirty="0"/>
           </a:p>
@@ -4489,7 +4489,7 @@
                 <a:ea typeface="IBM Plex Mono" pitchFamily="34" charset="-122"/>
                 <a:cs typeface="IBM Plex Mono" pitchFamily="34" charset="-120"/>
               </a:rPr>
-              <a:t>Luiza Britto · PAS — Projeto Aplicado em Sustentabilidade · Insper · 02 jul 2026</a:t>
+              <a:t>Luiza Britto · PAS — Programa Avançado de Sustentabilidade · Insper · 02 jul 2026</a:t>
             </a:r>
             <a:endParaRPr lang="en-US" sz="800" dirty="0"/>
           </a:p>
@@ -5959,7 +5959,7 @@
                 <a:ea typeface="IBM Plex Mono" pitchFamily="34" charset="-122"/>
                 <a:cs typeface="IBM Plex Mono" pitchFamily="34" charset="-120"/>
               </a:rPr>
-              <a:t>Luiza Britto · PAS — Projeto Aplicado em Sustentabilidade · Insper · 02 jul 2026</a:t>
+              <a:t>Luiza Britto · PAS — Programa Avançado de Sustentabilidade · Insper · 02 jul 2026</a:t>
             </a:r>
             <a:endParaRPr lang="en-US" sz="800" dirty="0"/>
           </a:p>
@@ -6504,7 +6504,7 @@
                 <a:ea typeface="IBM Plex Mono" pitchFamily="34" charset="-122"/>
                 <a:cs typeface="IBM Plex Mono" pitchFamily="34" charset="-120"/>
               </a:rPr>
-              <a:t>Luiza Britto · PAS — Projeto Aplicado em Sustentabilidade · Insper · 02 jul 2026</a:t>
+              <a:t>Luiza Britto · PAS — Programa Avançado de Sustentabilidade · Insper · 02 jul 2026</a:t>
             </a:r>
             <a:endParaRPr lang="en-US" sz="800" dirty="0"/>
           </a:p>
@@ -7028,7 +7028,7 @@
                 <a:ea typeface="IBM Plex Mono" pitchFamily="34" charset="-122"/>
                 <a:cs typeface="IBM Plex Mono" pitchFamily="34" charset="-120"/>
               </a:rPr>
-              <a:t>Luiza Britto · PAS — Projeto Aplicado em Sustentabilidade · Insper · 02 jul 2026</a:t>
+              <a:t>Luiza Britto · PAS — Programa Avançado de Sustentabilidade · Insper · 02 jul 2026</a:t>
             </a:r>
             <a:endParaRPr lang="en-US" sz="800" dirty="0"/>
           </a:p>
@@ -7759,7 +7759,7 @@
                 <a:ea typeface="IBM Plex Mono" pitchFamily="34" charset="-122"/>
                 <a:cs typeface="IBM Plex Mono" pitchFamily="34" charset="-120"/>
               </a:rPr>
-              <a:t>Luiza Britto · PAS — Projeto Aplicado em Sustentabilidade · Insper · 02 jul 2026</a:t>
+              <a:t>Luiza Britto · PAS — Programa Avançado de Sustentabilidade · Insper · 02 jul 2026</a:t>
             </a:r>
             <a:endParaRPr lang="en-US" sz="800" dirty="0"/>
           </a:p>
@@ -8819,7 +8819,7 @@
                 <a:ea typeface="IBM Plex Mono" pitchFamily="34" charset="-122"/>
                 <a:cs typeface="IBM Plex Mono" pitchFamily="34" charset="-120"/>
               </a:rPr>
-              <a:t>Luiza Britto · PAS — Projeto Aplicado em Sustentabilidade · Insper · 02 jul 2026</a:t>
+              <a:t>Luiza Britto · PAS — Programa Avançado de Sustentabilidade · Insper · 02 jul 2026</a:t>
             </a:r>
             <a:endParaRPr lang="en-US" sz="800" dirty="0"/>
           </a:p>
@@ -9138,7 +9138,7 @@
                 <a:ea typeface="IBM Plex Mono" pitchFamily="34" charset="-122"/>
                 <a:cs typeface="IBM Plex Mono" pitchFamily="34" charset="-120"/>
               </a:rPr>
-              <a:t>Luiza Britto · PAS — Projeto Aplicado em Sustentabilidade · Insper · 02 jul 2026</a:t>
+              <a:t>Luiza Britto · PAS — Programa Avançado de Sustentabilidade · Insper · 02 jul 2026</a:t>
             </a:r>
             <a:endParaRPr lang="en-US" sz="800" dirty="0"/>
           </a:p>
@@ -9719,7 +9719,7 @@
                 <a:ea typeface="IBM Plex Mono" pitchFamily="34" charset="-122"/>
                 <a:cs typeface="IBM Plex Mono" pitchFamily="34" charset="-120"/>
               </a:rPr>
-              <a:t>Luiza Britto · PAS — Projeto Aplicado em Sustentabilidade · Insper · 02 jul 2026</a:t>
+              <a:t>Luiza Britto · PAS — Programa Avançado de Sustentabilidade · Insper · 02 jul 2026</a:t>
             </a:r>
             <a:endParaRPr lang="en-US" sz="800" dirty="0"/>
           </a:p>
@@ -10513,7 +10513,7 @@
                 <a:ea typeface="IBM Plex Mono" pitchFamily="34" charset="-122"/>
                 <a:cs typeface="IBM Plex Mono" pitchFamily="34" charset="-120"/>
               </a:rPr>
-              <a:t>Luiza Britto · PAS — Projeto Aplicado em Sustentabilidade · Insper · 02 jul 2026</a:t>
+              <a:t>Luiza Britto · PAS — Programa Avançado de Sustentabilidade · Insper · 02 jul 2026</a:t>
             </a:r>
             <a:endParaRPr lang="en-US" sz="800" dirty="0"/>
           </a:p>

</xml_diff>